<commit_message>
docs(worklog): daily record 2026-09-08
</commit_message>
<xml_diff>
--- a/docs/share/识图-Cursor协作复盘.pptx
+++ b/docs/share/识图-Cursor协作复盘.pptx
@@ -6819,6 +6819,38 @@
               <a:t>•  不记踩坑：同样的百度编码、路径中文问题会重复出现</a:t>
             </a:r>
           </a:p>
+          <a:p>
+            <a:pPr>
+              <a:spcAft>
+                <a:spcPts val="900"/>
+              </a:spcAft>
+            </a:pPr>
+            <a:r>
+              <a:rPr sz="1700" b="0">
+                <a:solidFill>
+                  <a:srgbClr val="1A1A1A"/>
+                </a:solidFill>
+                <a:latin typeface="PingFang SC"/>
+              </a:rPr>
+              <a:t>•  所有小事都套自定义工作流：流程过重，简单改动也又问又记又同步 —— 要控制边界，匹配任务体量</a:t>
+            </a:r>
+          </a:p>
+          <a:p>
+            <a:pPr>
+              <a:spcAft>
+                <a:spcPts val="900"/>
+              </a:spcAft>
+            </a:pPr>
+            <a:r>
+              <a:rPr sz="1700" b="0">
+                <a:solidFill>
+                  <a:srgbClr val="1A1A1A"/>
+                </a:solidFill>
+                <a:latin typeface="PingFang SC"/>
+              </a:rPr>
+              <a:t>•  自以为是 / 信息不全：缺失处 AI 会乱给默认值（色、文案、交互），验收时才发现「不是我要的」</a:t>
+            </a:r>
+          </a:p>
         </p:txBody>
       </p:sp>
       <p:sp>
@@ -7759,7 +7791,7 @@
                 </a:solidFill>
                 <a:latin typeface="PingFang SC"/>
               </a:rPr>
-              <a:t>给想学用 AI 的人：7 个习惯</a:t>
+              <a:t>给想学用 AI 的人：9 个习惯</a:t>
             </a:r>
           </a:p>
         </p:txBody>
@@ -7938,6 +7970,38 @@
                 <a:latin typeface="PingFang SC"/>
               </a:rPr>
               <a:t>•  定期复盘：这周 AI 帮我加速了什么？我又亲自做了哪些判断？</a:t>
+            </a:r>
+          </a:p>
+          <a:p>
+            <a:pPr>
+              <a:spcAft>
+                <a:spcPts val="900"/>
+              </a:spcAft>
+            </a:pPr>
+            <a:r>
+              <a:rPr sz="1700" b="0">
+                <a:solidFill>
+                  <a:srgbClr val="1A1A1A"/>
+                </a:solidFill>
+                <a:latin typeface="PingFang SC"/>
+              </a:rPr>
+              <a:t>•  控制边界：不要所有任务都套某个自定义工作流；小事先说清直改，复杂事再走完整循环</a:t>
+            </a:r>
+          </a:p>
+          <a:p>
+            <a:pPr>
+              <a:spcAft>
+                <a:spcPts val="900"/>
+              </a:spcAft>
+            </a:pPr>
+            <a:r>
+              <a:rPr sz="1700" b="0">
+                <a:solidFill>
+                  <a:srgbClr val="1A1A1A"/>
+                </a:solidFill>
+                <a:latin typeface="PingFang SC"/>
+              </a:rPr>
+              <a:t>•  不要自以为是：没说清的地方 AI 会乱给默认值；关键细节宁可多问一句，也不要默认它「懂你」</a:t>
             </a:r>
           </a:p>
         </p:txBody>
@@ -8411,7 +8475,7 @@
                 </a:solidFill>
                 <a:latin typeface="PingFang SC"/>
               </a:rPr>
-              <a:t>如果只记住三句</a:t>
+              <a:t>如果只记住几句</a:t>
             </a:r>
           </a:p>
         </p:txBody>
@@ -8526,6 +8590,38 @@
                 <a:latin typeface="PingFang SC"/>
               </a:rPr>
               <a:t>•  把好用的约定写成文件/规则，让下次的 AI（和自己）继承</a:t>
+            </a:r>
+          </a:p>
+          <a:p>
+            <a:pPr>
+              <a:spcAft>
+                <a:spcPts val="900"/>
+              </a:spcAft>
+            </a:pPr>
+            <a:r>
+              <a:rPr sz="1700" b="0">
+                <a:solidFill>
+                  <a:srgbClr val="1A1A1A"/>
+                </a:solidFill>
+                <a:latin typeface="PingFang SC"/>
+              </a:rPr>
+              <a:t>•  控制边界：自定义工作流别滥用，匹配任务体量</a:t>
+            </a:r>
+          </a:p>
+          <a:p>
+            <a:pPr>
+              <a:spcAft>
+                <a:spcPts val="900"/>
+              </a:spcAft>
+            </a:pPr>
+            <a:r>
+              <a:rPr sz="1700" b="0">
+                <a:solidFill>
+                  <a:srgbClr val="1A1A1A"/>
+                </a:solidFill>
+                <a:latin typeface="PingFang SC"/>
+              </a:rPr>
+              <a:t>•  不要自以为是：缺失的地方 AI 会乱给默认值</a:t>
             </a:r>
           </a:p>
         </p:txBody>
@@ -9050,6 +9146,22 @@
               <a:t>•  真正要学的技能：说清楚、会拍板、会验收、会把经验写下来</a:t>
             </a:r>
           </a:p>
+          <a:p>
+            <a:pPr>
+              <a:spcAft>
+                <a:spcPts val="900"/>
+              </a:spcAft>
+            </a:pPr>
+            <a:r>
+              <a:rPr sz="1700" b="0">
+                <a:solidFill>
+                  <a:srgbClr val="1A1A1A"/>
+                </a:solidFill>
+                <a:latin typeface="PingFang SC"/>
+              </a:rPr>
+              <a:t>•  缺约束时 AI 会乱给默认值 —— 别假设它懂你没说出口的细节</a:t>
+            </a:r>
+          </a:p>
         </p:txBody>
       </p:sp>
       <p:sp>
@@ -9893,7 +10005,7 @@
                 </a:solidFill>
                 <a:latin typeface="PingFang SC"/>
               </a:rPr>
-              <a:t>我用的固定循环（每次任务都尽量走一遍）</a:t>
+              <a:t>我用的固定循环（适合有决策的任务，不是事事套用）</a:t>
             </a:r>
           </a:p>
         </p:txBody>
@@ -11183,7 +11295,18 @@
                 </a:solidFill>
                 <a:latin typeface="PingFang SC"/>
               </a:rPr>
-              <a:t>跳过第 2、3 步（选项 + 拍板）直接写 → 最容易返工。识图取景框就是这样踩的坑。</a:t>
+              <a:t>有歧义/要拍板时：走完选项→拍板，别跳过。小改文案、改个颜色：直接说清就改，不必套完整工作流。</a:t>
+            </a:r>
+          </a:p>
+          <a:p>
+            <a:r>
+              <a:rPr sz="1400" b="0">
+                <a:solidFill>
+                  <a:srgbClr val="727272"/>
+                </a:solidFill>
+                <a:latin typeface="PingFang SC"/>
+              </a:rPr>
+              <a:t>注意控制边界：不要所有任务都套某个自定义工作流——流程是工具，过重会拖慢。</a:t>
             </a:r>
           </a:p>
         </p:txBody>
@@ -11502,6 +11625,22 @@
                 <a:latin typeface="PingFang SC"/>
               </a:rPr>
               <a:t>•  不确定时主动要求它先问你：「有两种理解就先别改」</a:t>
+            </a:r>
+          </a:p>
+          <a:p>
+            <a:pPr>
+              <a:spcAft>
+                <a:spcPts val="900"/>
+              </a:spcAft>
+            </a:pPr>
+            <a:r>
+              <a:rPr sz="1700" b="0">
+                <a:solidFill>
+                  <a:srgbClr val="1A1A1A"/>
+                </a:solidFill>
+                <a:latin typeface="PingFang SC"/>
+              </a:rPr>
+              <a:t>•  不要自以为是：缺的约束 AI 会乱填默认值 —— 没说清的颜色/文案/行为，宁可先问你</a:t>
             </a:r>
           </a:p>
         </p:txBody>

</xml_diff>